<commit_message>
docs: agregar investigación y divulgación coordinada
</commit_message>
<xml_diff>
--- a/classes/parte-0-fundamentos-y-prerrequisitos/004-montaje-del-laboratorio-virtualizacion-kali-snapshots-y-aislamiento-de-red/clase-004-presentacion.pptx
+++ b/classes/parte-0-fundamentos-y-prerrequisitos/004-montaje-del-laboratorio-virtualizacion-kali-snapshots-y-aislamiento-de-red/clase-004-presentacion.pptx
@@ -3418,22 +3418,97 @@
                   <a:srgbClr val="22282E"/>
                 </a:solidFill>
               </a:rPr>
-              <a:t>•  Entrega un laboratorio funcional con al menos dos VMs (Kali más una víctima) en una red interna aislada, con IPs estáticas documentadas y un snapshot base-limpia por VM. Adjunta capturas de: (a) ping…</a:t>
-            </a:r>
-          </a:p>
-          <a:p>
-            <a:pPr>
-              <a:spcAft>
-                <a:spcPts val="600"/>
-              </a:spcAft>
-            </a:pPr>
-            <a:r>
-              <a:rPr sz="1500">
-                <a:solidFill>
-                  <a:srgbClr val="22282E"/>
-                </a:solidFill>
-              </a:rPr>
-              <a:t>•  Criterio de aceptación: Kali alcanza a la víctima por la red interna pero ninguna VM alcanza Internet, y restaurar el snapshot devuelve la VM a un estado limpio verificable. Cualquier persona con tus…</a:t>
+              <a:t>•  Entrega un laboratorio funcional con al menos dos VMs (una estación de seguridad más una víctima)</a:t>
+            </a:r>
+          </a:p>
+          <a:p>
+            <a:pPr>
+              <a:spcAft>
+                <a:spcPts val="600"/>
+              </a:spcAft>
+            </a:pPr>
+            <a:r>
+              <a:rPr sz="1500">
+                <a:solidFill>
+                  <a:srgbClr val="22282E"/>
+                </a:solidFill>
+              </a:rPr>
+              <a:t>•  en una red interna aislada, con IPs estáticas documentadas y un snapshot base-limpia-AAAA-MM-DD</a:t>
+            </a:r>
+          </a:p>
+          <a:p>
+            <a:pPr>
+              <a:spcAft>
+                <a:spcPts val="600"/>
+              </a:spcAft>
+            </a:pPr>
+            <a:r>
+              <a:rPr sz="1500">
+                <a:solidFill>
+                  <a:srgbClr val="22282E"/>
+                </a:solidFill>
+              </a:rPr>
+              <a:t>•  por VM. Incluye manifiesto de distribución, imagen, hash, paquetes relevantes y versiones. Adjunta</a:t>
+            </a:r>
+          </a:p>
+          <a:p>
+            <a:pPr>
+              <a:spcAft>
+                <a:spcPts val="600"/>
+              </a:spcAft>
+            </a:pPr>
+            <a:r>
+              <a:rPr sz="1500">
+                <a:solidFill>
+                  <a:srgbClr val="22282E"/>
+                </a:solidFill>
+              </a:rPr>
+              <a:t>•  evidencia de: (a) conectividad interna exitosa, (b) salida a Internet fallida, (c) snapshots y</a:t>
+            </a:r>
+          </a:p>
+          <a:p>
+            <a:pPr>
+              <a:spcAft>
+                <a:spcPts val="600"/>
+              </a:spcAft>
+            </a:pPr>
+            <a:r>
+              <a:rPr sz="1500">
+                <a:solidFill>
+                  <a:srgbClr val="22282E"/>
+                </a:solidFill>
+              </a:rPr>
+              <a:t>•  (d) la misma capacidad inocua ejecutada desde dos entornos o una justificación reproducible de la</a:t>
+            </a:r>
+          </a:p>
+          <a:p>
+            <a:pPr>
+              <a:spcAft>
+                <a:spcPts val="600"/>
+              </a:spcAft>
+            </a:pPr>
+            <a:r>
+              <a:rPr sz="1500">
+                <a:solidFill>
+                  <a:srgbClr val="22282E"/>
+                </a:solidFill>
+              </a:rPr>
+              <a:t>•  equivalencia.</a:t>
+            </a:r>
+          </a:p>
+          <a:p>
+            <a:pPr>
+              <a:spcAft>
+                <a:spcPts val="600"/>
+              </a:spcAft>
+            </a:pPr>
+            <a:r>
+              <a:rPr sz="1500">
+                <a:solidFill>
+                  <a:srgbClr val="22282E"/>
+                </a:solidFill>
+              </a:rPr>
+              <a:t>•  Criterio de aceptación: la estación alcanza a la víctima por la red interna pero ninguna VM</a:t>
             </a:r>
           </a:p>
         </p:txBody>
@@ -3701,52 +3776,82 @@
                   <a:srgbClr val="22282E"/>
                 </a:solidFill>
               </a:rPr>
-              <a:t>•  ❓ ¿VirtualBox o VMware? Ambos sirven para el curso. VirtualBox es gratuito y multiplataforma; VMware suele rendir algo mejor. Elige uno y sé consistente para no dispersarte con dos flujos distintos.</a:t>
-            </a:r>
-          </a:p>
-          <a:p>
-            <a:pPr>
-              <a:spcAft>
-                <a:spcPts val="600"/>
-              </a:spcAft>
-            </a:pPr>
-            <a:r>
-              <a:rPr sz="1500">
-                <a:solidFill>
-                  <a:srgbClr val="22282E"/>
-                </a:solidFill>
-              </a:rPr>
-              <a:t>•  ❓ ¿Por qué red interna y no host-only? Host-only deja al anfitrión dentro de la red del lab; la red interna aísla aún más, dejando las VMs solas entre sí. Para prácticas con malware, cuanto más…</a:t>
-            </a:r>
-          </a:p>
-          <a:p>
-            <a:pPr>
-              <a:spcAft>
-                <a:spcPts val="600"/>
-              </a:spcAft>
-            </a:pPr>
-            <a:r>
-              <a:rPr sz="1500">
-                <a:solidFill>
-                  <a:srgbClr val="22282E"/>
-                </a:solidFill>
-              </a:rPr>
-              <a:t>•  ❓ ¿Necesito mucha RAM? Con 8 GB puedes correr Kali más una víctima. Con 16 GB trabajas cómodo con varios nodos simultáneos. La RAM suele ser el recurso que primero se agota al añadir máquinas.</a:t>
-            </a:r>
-          </a:p>
-          <a:p>
-            <a:pPr>
-              <a:spcAft>
-                <a:spcPts val="600"/>
-              </a:spcAft>
-            </a:pPr>
-            <a:r>
-              <a:rPr sz="1500">
-                <a:solidFill>
-                  <a:srgbClr val="22282E"/>
-                </a:solidFill>
-              </a:rPr>
-              <a:t>•  ❓ ¿Cada cuánto tomo snapshots? Uno base-limpia tras instalar y actualizar cada VM, y uno más antes de cualquier experimento arriesgado. Después, limpia los que ya no aporten para no llenar el disco…</a:t>
+              <a:t>•  ❓ ¿Qué distribución exige el curso? Ninguna. Kali es la referencia porque reduce fricción,</a:t>
+            </a:r>
+          </a:p>
+          <a:p>
+            <a:pPr>
+              <a:spcAft>
+                <a:spcPts val="600"/>
+              </a:spcAft>
+            </a:pPr>
+            <a:r>
+              <a:rPr sz="1500">
+                <a:solidFill>
+                  <a:srgbClr val="22282E"/>
+                </a:solidFill>
+              </a:rPr>
+              <a:t>•  pero puedes usar Parrot, Linux general, Windows o macOS cuando exista una implementación equivalente.</a:t>
+            </a:r>
+          </a:p>
+          <a:p>
+            <a:pPr>
+              <a:spcAft>
+                <a:spcPts val="600"/>
+              </a:spcAft>
+            </a:pPr>
+            <a:r>
+              <a:rPr sz="1500">
+                <a:solidFill>
+                  <a:srgbClr val="22282E"/>
+                </a:solidFill>
+              </a:rPr>
+              <a:t>•  Debes documentar herramienta, versión y diferencias. Security Onion aparece como plataforma</a:t>
+            </a:r>
+          </a:p>
+          <a:p>
+            <a:pPr>
+              <a:spcAft>
+                <a:spcPts val="600"/>
+              </a:spcAft>
+            </a:pPr>
+            <a:r>
+              <a:rPr sz="1500">
+                <a:solidFill>
+                  <a:srgbClr val="22282E"/>
+                </a:solidFill>
+              </a:rPr>
+              <a:t>•  defensiva y BlackArch como variante avanzada, no como requisitos acumulativos.</a:t>
+            </a:r>
+          </a:p>
+          <a:p>
+            <a:pPr>
+              <a:spcAft>
+                <a:spcPts val="600"/>
+              </a:spcAft>
+            </a:pPr>
+            <a:r>
+              <a:rPr sz="1500">
+                <a:solidFill>
+                  <a:srgbClr val="22282E"/>
+                </a:solidFill>
+              </a:rPr>
+              <a:t>•  ❓ ¿Debo instalar todas las herramientas? No. Instala el conjunto mínimo para la clase. Una</a:t>
+            </a:r>
+          </a:p>
+          <a:p>
+            <a:pPr>
+              <a:spcAft>
+                <a:spcPts val="600"/>
+              </a:spcAft>
+            </a:pPr>
+            <a:r>
+              <a:rPr sz="1500">
+                <a:solidFill>
+                  <a:srgbClr val="22282E"/>
+                </a:solidFill>
+              </a:rPr>
+              <a:t>•  imagen enorme consume recursos, amplía la superficie y hace menos claro qué dependencia produjo el</a:t>
             </a:r>
           </a:p>
         </p:txBody>
@@ -3850,37 +3955,82 @@
                   <a:srgbClr val="22282E"/>
                 </a:solidFill>
               </a:rPr>
-              <a:t>•  Oracle VirtualBox Manual — &lt;https://www.virtualbox.org/manual/&gt;</a:t>
-            </a:r>
-          </a:p>
-          <a:p>
-            <a:pPr>
-              <a:spcAft>
-                <a:spcPts val="600"/>
-              </a:spcAft>
-            </a:pPr>
-            <a:r>
-              <a:rPr sz="1500">
-                <a:solidFill>
-                  <a:srgbClr val="22282E"/>
-                </a:solidFill>
-              </a:rPr>
-              <a:t>•  Rapid7 Metasploitable 2 — &lt;https://docs.rapid7.com/metasploit/metasploitable-2/&gt;</a:t>
-            </a:r>
-          </a:p>
-          <a:p>
-            <a:pPr>
-              <a:spcAft>
-                <a:spcPts val="600"/>
-              </a:spcAft>
-            </a:pPr>
-            <a:r>
-              <a:rPr sz="1500">
-                <a:solidFill>
-                  <a:srgbClr val="22282E"/>
-                </a:solidFill>
-              </a:rPr>
-              <a:t>•  OWASP DVWA — &lt;https://github.com/digininja/DVWA&gt;</a:t>
+              <a:t>•  Kali Linux — tipos de imagen — &lt;https://www.kali.org/docs/introduction/what-image-to-download/&gt;</a:t>
+            </a:r>
+          </a:p>
+          <a:p>
+            <a:pPr>
+              <a:spcAft>
+                <a:spcPts val="600"/>
+              </a:spcAft>
+            </a:pPr>
+            <a:r>
+              <a:rPr sz="1500">
+                <a:solidFill>
+                  <a:srgbClr val="22282E"/>
+                </a:solidFill>
+              </a:rPr>
+              <a:t>•  Kali Linux — actualización — &lt;https://www.kali.org/docs/general-use/updating-kali/&gt;</a:t>
+            </a:r>
+          </a:p>
+          <a:p>
+            <a:pPr>
+              <a:spcAft>
+                <a:spcPts val="600"/>
+              </a:spcAft>
+            </a:pPr>
+            <a:r>
+              <a:rPr sz="1500">
+                <a:solidFill>
+                  <a:srgbClr val="22282E"/>
+                </a:solidFill>
+              </a:rPr>
+              <a:t>•  Kali Linux — metapaquetes — &lt;https://www.kali.org/docs/general-use/metapackages/&gt;</a:t>
+            </a:r>
+          </a:p>
+          <a:p>
+            <a:pPr>
+              <a:spcAft>
+                <a:spcPts val="600"/>
+              </a:spcAft>
+            </a:pPr>
+            <a:r>
+              <a:rPr sz="1500">
+                <a:solidFill>
+                  <a:srgbClr val="22282E"/>
+                </a:solidFill>
+              </a:rPr>
+              <a:t>•  ParrotOS — ediciones e imágenes — &lt;https://www.parrotsec.org/docs/introduction/download-parrot/&gt;</a:t>
+            </a:r>
+          </a:p>
+          <a:p>
+            <a:pPr>
+              <a:spcAft>
+                <a:spcPts val="600"/>
+              </a:spcAft>
+            </a:pPr>
+            <a:r>
+              <a:rPr sz="1500">
+                <a:solidFill>
+                  <a:srgbClr val="22282E"/>
+                </a:solidFill>
+              </a:rPr>
+              <a:t>•  ParrotOS — gestión de software — &lt;https://www.parrotsec.org/docs/configuration/parrot-software-management/&gt;</a:t>
+            </a:r>
+          </a:p>
+          <a:p>
+            <a:pPr>
+              <a:spcAft>
+                <a:spcPts val="600"/>
+              </a:spcAft>
+            </a:pPr>
+            <a:r>
+              <a:rPr sz="1500">
+                <a:solidFill>
+                  <a:srgbClr val="22282E"/>
+                </a:solidFill>
+              </a:rPr>
+              <a:t>•  BlackArch — descargas e instalación oficial — &lt;https://blackarch.org/downloads.html&gt;</a:t>
             </a:r>
           </a:p>
         </p:txBody>
@@ -4044,7 +4194,97 @@
                   <a:srgbClr val="22282E"/>
                 </a:solidFill>
               </a:rPr>
-              <a:t>•  Construir un laboratorio de seguridad aislado y reversible en tu propio equipo. Practicar técnicas ofensivas requiere un entorno donde el error no tenga consecuencias fuera de él: una red que no…</a:t>
+              <a:t>•  Construir un laboratorio de seguridad aislado, reversible y reproducible en tu propio equipo.</a:t>
+            </a:r>
+          </a:p>
+          <a:p>
+            <a:pPr>
+              <a:spcAft>
+                <a:spcPts val="600"/>
+              </a:spcAft>
+            </a:pPr>
+            <a:r>
+              <a:rPr sz="1500">
+                <a:solidFill>
+                  <a:srgbClr val="22282E"/>
+                </a:solidFill>
+              </a:rPr>
+              <a:t>•  Practicar técnicas ofensivas requiere un entorno donde el error no tenga consecuencias fuera de</a:t>
+            </a:r>
+          </a:p>
+          <a:p>
+            <a:pPr>
+              <a:spcAft>
+                <a:spcPts val="600"/>
+              </a:spcAft>
+            </a:pPr>
+            <a:r>
+              <a:rPr sz="1500">
+                <a:solidFill>
+                  <a:srgbClr val="22282E"/>
+                </a:solidFill>
+              </a:rPr>
+              <a:t>•  él: una red que no toque Internet ni tu red doméstica, y máquinas que puedas devolver a un estado</a:t>
+            </a:r>
+          </a:p>
+          <a:p>
+            <a:pPr>
+              <a:spcAft>
+                <a:spcPts val="600"/>
+              </a:spcAft>
+            </a:pPr>
+            <a:r>
+              <a:rPr sz="1500">
+                <a:solidFill>
+                  <a:srgbClr val="22282E"/>
+                </a:solidFill>
+              </a:rPr>
+              <a:t>•  limpio en segundos. Al terminar tendrás una estación de trabajo de seguridad y una o más máquinas</a:t>
+            </a:r>
+          </a:p>
+          <a:p>
+            <a:pPr>
+              <a:spcAft>
+                <a:spcPts val="600"/>
+              </a:spcAft>
+            </a:pPr>
+            <a:r>
+              <a:rPr sz="1500">
+                <a:solidFill>
+                  <a:srgbClr val="22282E"/>
+                </a:solidFill>
+              </a:rPr>
+              <a:t>•  víctima en una red interna sin salida. Aprenderás a elegir entre Kali, Parrot, BlackArch y una</a:t>
+            </a:r>
+          </a:p>
+          <a:p>
+            <a:pPr>
+              <a:spcAft>
+                <a:spcPts val="600"/>
+              </a:spcAft>
+            </a:pPr>
+            <a:r>
+              <a:rPr sz="1500">
+                <a:solidFill>
+                  <a:srgbClr val="22282E"/>
+                </a:solidFill>
+              </a:rPr>
+              <a:t>•  plataforma defensiva como Security Onion, a instalarlas y mantenerlas sin confundir una colección</a:t>
+            </a:r>
+          </a:p>
+          <a:p>
+            <a:pPr>
+              <a:spcAft>
+                <a:spcPts val="600"/>
+              </a:spcAft>
+            </a:pPr>
+            <a:r>
+              <a:rPr sz="1500">
+                <a:solidFill>
+                  <a:srgbClr val="22282E"/>
+                </a:solidFill>
+              </a:rPr>
+              <a:t>•  de herramientas con una metodología.</a:t>
             </a:r>
           </a:p>
         </p:txBody>
@@ -4163,7 +4403,7 @@
                   <a:srgbClr val="22282E"/>
                 </a:solidFill>
               </a:rPr>
-              <a:t>•  Desplegar Kali Linux y una VM víctima desde imágenes oficiales verificadas.</a:t>
+              <a:t>•  Desplegar una distribución de seguridad y una VM víctima desde imágenes oficiales verificadas.</a:t>
             </a:r>
           </a:p>
           <a:p>
@@ -4521,67 +4761,67 @@
                   <a:srgbClr val="22282E"/>
                 </a:solidFill>
               </a:rPr>
-              <a:t>•  La decisión más importante del laboratorio es cómo conectas las VMs, porque de ahí depende que el entorno sea seguro. Los hipervisores ofrecen cuatro modos y cada uno tiene un nivel de aislamiento…</a:t>
-            </a:r>
-          </a:p>
-          <a:p>
-            <a:pPr>
-              <a:spcAft>
-                <a:spcPts val="600"/>
-              </a:spcAft>
-            </a:pPr>
-            <a:r>
-              <a:rPr sz="1500">
-                <a:solidFill>
-                  <a:srgbClr val="22282E"/>
-                </a:solidFill>
-              </a:rPr>
-              <a:t>•  Modo de red — Quién ve a quién</a:t>
-            </a:r>
-          </a:p>
-          <a:p>
-            <a:pPr>
-              <a:spcAft>
-                <a:spcPts val="600"/>
-              </a:spcAft>
-            </a:pPr>
-            <a:r>
-              <a:rPr sz="1500">
-                <a:solidFill>
-                  <a:srgbClr val="22282E"/>
-                </a:solidFill>
-              </a:rPr>
-              <a:t>•  NAT — La VM sale, nadie entra a ella</a:t>
-            </a:r>
-          </a:p>
-          <a:p>
-            <a:pPr>
-              <a:spcAft>
-                <a:spcPts val="600"/>
-              </a:spcAft>
-            </a:pPr>
-            <a:r>
-              <a:rPr sz="1500">
-                <a:solidFill>
-                  <a:srgbClr val="22282E"/>
-                </a:solidFill>
-              </a:rPr>
-              <a:t>•  Bridged (puente) — La VM es un equipo más de tu LAN</a:t>
-            </a:r>
-          </a:p>
-          <a:p>
-            <a:pPr>
-              <a:spcAft>
-                <a:spcPts val="600"/>
-              </a:spcAft>
-            </a:pPr>
-            <a:r>
-              <a:rPr sz="1500">
-                <a:solidFill>
-                  <a:srgbClr val="22282E"/>
-                </a:solidFill>
-              </a:rPr>
-              <a:t>•  Host-only — VM ↔ host, pero no a Internet</a:t>
+              <a:t>•  Una distribución especializada combina un Linux base, repositorios, configuración y una selección</a:t>
+            </a:r>
+          </a:p>
+          <a:p>
+            <a:pPr>
+              <a:spcAft>
+                <a:spcPts val="600"/>
+              </a:spcAft>
+            </a:pPr>
+            <a:r>
+              <a:rPr sz="1500">
+                <a:solidFill>
+                  <a:srgbClr val="22282E"/>
+                </a:solidFill>
+              </a:rPr>
+              <a:t>•  de herramientas. Ahorra instalación y facilita laboratorios reproducibles, pero no concede permisos,</a:t>
+            </a:r>
+          </a:p>
+          <a:p>
+            <a:pPr>
+              <a:spcAft>
+                <a:spcPts val="600"/>
+              </a:spcAft>
+            </a:pPr>
+            <a:r>
+              <a:rPr sz="1500">
+                <a:solidFill>
+                  <a:srgbClr val="22282E"/>
+                </a:solidFill>
+              </a:rPr>
+              <a:t>•  no reemplaza los fundamentos y no hace que una herramienta sea segura por estar en su menú. Cuantas</a:t>
+            </a:r>
+          </a:p>
+          <a:p>
+            <a:pPr>
+              <a:spcAft>
+                <a:spcPts val="600"/>
+              </a:spcAft>
+            </a:pPr>
+            <a:r>
+              <a:rPr sz="1500">
+                <a:solidFill>
+                  <a:srgbClr val="22282E"/>
+                </a:solidFill>
+              </a:rPr>
+              <a:t>•  más utilidades instales, más espacio, actualizaciones, dependencias y superficie debes gestionar.</a:t>
+            </a:r>
+          </a:p>
+          <a:p>
+            <a:pPr>
+              <a:spcAft>
+                <a:spcPts val="600"/>
+              </a:spcAft>
+            </a:pPr>
+            <a:r>
+              <a:rPr sz="1500">
+                <a:solidFill>
+                  <a:srgbClr val="22282E"/>
+                </a:solidFill>
+              </a:rPr>
+              <a:t>•  Entorno — Base y propósito</a:t>
             </a:r>
           </a:p>
         </p:txBody>
@@ -5028,7 +5268,97 @@
                   <a:srgbClr val="22282E"/>
                 </a:solidFill>
               </a:rPr>
-              <a:t>•  Instala VirtualBox (gratuito y multiplataforma) o VMware Workstation Player. Descarga la imagen oficial de Kali Linux desde &lt;https://www.kali.org/get-kali/&gt; y una máquina víctima como Metasploitable…</a:t>
+              <a:t>•  Instala VirtualBox, VMware Workstation o el hipervisor que ya administres. Descarga una VM/ISO</a:t>
+            </a:r>
+          </a:p>
+          <a:p>
+            <a:pPr>
+              <a:spcAft>
+                <a:spcPts val="600"/>
+              </a:spcAft>
+            </a:pPr>
+            <a:r>
+              <a:rPr sz="1500">
+                <a:solidFill>
+                  <a:srgbClr val="22282E"/>
+                </a:solidFill>
+              </a:rPr>
+              <a:t>•  oficial de Kali Linux o Parrot Security y una víctima diseñada para practicar, como</a:t>
+            </a:r>
+          </a:p>
+          <a:p>
+            <a:pPr>
+              <a:spcAft>
+                <a:spcPts val="600"/>
+              </a:spcAft>
+            </a:pPr>
+            <a:r>
+              <a:rPr sz="1500">
+                <a:solidFill>
+                  <a:srgbClr val="22282E"/>
+                </a:solidFill>
+              </a:rPr>
+              <a:t>•  Metasploitable 2 o DVWA. BlackArch queda como variante avanzada. Security Onion se instala en una</a:t>
+            </a:r>
+          </a:p>
+          <a:p>
+            <a:pPr>
+              <a:spcAft>
+                <a:spcPts val="600"/>
+              </a:spcAft>
+            </a:pPr>
+            <a:r>
+              <a:rPr sz="1500">
+                <a:solidFill>
+                  <a:srgbClr val="22282E"/>
+                </a:solidFill>
+              </a:rPr>
+              <a:t>•  VM aparte cuando llegues a prácticas defensivas y el equipo cumpla sus requisitos; no lo añadas al</a:t>
+            </a:r>
+          </a:p>
+          <a:p>
+            <a:pPr>
+              <a:spcAft>
+                <a:spcPts val="600"/>
+              </a:spcAft>
+            </a:pPr>
+            <a:r>
+              <a:rPr sz="1500">
+                <a:solidFill>
+                  <a:srgbClr val="22282E"/>
+                </a:solidFill>
+              </a:rPr>
+              <a:t>•  laboratorio inicial por coleccionismo.</a:t>
+            </a:r>
+          </a:p>
+          <a:p>
+            <a:pPr>
+              <a:spcAft>
+                <a:spcPts val="600"/>
+              </a:spcAft>
+            </a:pPr>
+            <a:r>
+              <a:rPr sz="1500">
+                <a:solidFill>
+                  <a:srgbClr val="22282E"/>
+                </a:solidFill>
+              </a:rPr>
+              <a:t>•  Verifica el hash y, si el proyecto la ofrece, la firma. Comprueba VT-x/AMD-V, espacio y RAM. Como</a:t>
+            </a:r>
+          </a:p>
+          <a:p>
+            <a:pPr>
+              <a:spcAft>
+                <a:spcPts val="600"/>
+              </a:spcAft>
+            </a:pPr>
+            <a:r>
+              <a:rPr sz="1500">
+                <a:solidFill>
+                  <a:srgbClr val="22282E"/>
+                </a:solidFill>
+              </a:rPr>
+              <a:t>•  referencia pedagógica, 8 GB de RAM permite una VM de escritorio y una víctima pequeña; 16 GB da más</a:t>
             </a:r>
           </a:p>
         </p:txBody>
@@ -5132,7 +5462,52 @@
                   <a:srgbClr val="22282E"/>
                 </a:solidFill>
               </a:rPr>
-              <a:t>•  Verificar la ISO de Kali. Descarga la imagen y su checksum oficial. En PowerShell:</a:t>
+              <a:t>•  Elegir y registrar el entorno. Escribe misión, distribución/edición, arquitectura, tipo de</a:t>
+            </a:r>
+          </a:p>
+          <a:p>
+            <a:pPr>
+              <a:spcAft>
+                <a:spcPts val="600"/>
+              </a:spcAft>
+            </a:pPr>
+            <a:r>
+              <a:rPr sz="1500">
+                <a:solidFill>
+                  <a:srgbClr val="22282E"/>
+                </a:solidFill>
+              </a:rPr>
+              <a:t>•  imagen, URL oficial, fecha y recursos asignados. Justifica por qué Kali, Parrot o tu Linux normal</a:t>
+            </a:r>
+          </a:p>
+          <a:p>
+            <a:pPr>
+              <a:spcAft>
+                <a:spcPts val="600"/>
+              </a:spcAft>
+            </a:pPr>
+            <a:r>
+              <a:rPr sz="1500">
+                <a:solidFill>
+                  <a:srgbClr val="22282E"/>
+                </a:solidFill>
+              </a:rPr>
+              <a:t>•  cubre la práctica sin instalar herramientas innecesarias.</a:t>
+            </a:r>
+          </a:p>
+          <a:p>
+            <a:pPr>
+              <a:spcAft>
+                <a:spcPts val="600"/>
+              </a:spcAft>
+            </a:pPr>
+            <a:r>
+              <a:rPr sz="1500">
+                <a:solidFill>
+                  <a:srgbClr val="22282E"/>
+                </a:solidFill>
+              </a:rPr>
+              <a:t>•  Verificar la imagen. Descarga la imagen y su checksum oficial. En PowerShell:</a:t>
             </a:r>
           </a:p>
           <a:p>
@@ -5162,52 +5537,7 @@
                   <a:srgbClr val="22282E"/>
                 </a:solidFill>
               </a:rPr>
-              <a:t>•  Crear la VM Kali en VirtualBox: 2 vCPU, 4 GB de RAM y 40 GB de disco. Monta la ISO y completa la instalación gráfica.</a:t>
-            </a:r>
-          </a:p>
-          <a:p>
-            <a:pPr>
-              <a:spcAft>
-                <a:spcPts val="600"/>
-              </a:spcAft>
-            </a:pPr>
-            <a:r>
-              <a:rPr sz="1500">
-                <a:solidFill>
-                  <a:srgbClr val="22282E"/>
-                </a:solidFill>
-              </a:rPr>
-              <a:t>•  Crear la red interna. En VirtualBox, en la configuración de cada VM → Red, selecciona "Red interna" y ponle el nombre lab-net. Asigna ese adaptador tanto a Kali como a la víctima.</a:t>
-            </a:r>
-          </a:p>
-          <a:p>
-            <a:pPr>
-              <a:spcAft>
-                <a:spcPts val="600"/>
-              </a:spcAft>
-            </a:pPr>
-            <a:r>
-              <a:rPr sz="1500">
-                <a:solidFill>
-                  <a:srgbClr val="22282E"/>
-                </a:solidFill>
-              </a:rPr>
-              <a:t>•  Desplegar la víctima (Metasploitable) importando su OVA/OVF y conectándola a lab-net.</a:t>
-            </a:r>
-          </a:p>
-          <a:p>
-            <a:pPr>
-              <a:spcAft>
-                <a:spcPts val="600"/>
-              </a:spcAft>
-            </a:pPr>
-            <a:r>
-              <a:rPr sz="1500">
-                <a:solidFill>
-                  <a:srgbClr val="22282E"/>
-                </a:solidFill>
-              </a:rPr>
-              <a:t>•  Direccionar. Configura IPs estáticas en la misma subred, por ejemplo Kali 10.10.10.5 y víctima 10.10.10.6, con máscara /24.</a:t>
+              <a:t>•  Crear la VM de seguridad: 2 vCPU, 4 GB de RAM y 40–60 GB de disco como punto de partida</a:t>
             </a:r>
           </a:p>
         </p:txBody>

</xml_diff>